<commit_message>
Fix connector count: 26 → 29 throughout docs and presentation
Corrected count across all references:
- CLAUDE.md: project overview and connectors layout comment
- README.md: project structure comment
- IMPLEMENTATION_PLAN.md: package structure comment
- scripts/build_presentation.js: problem slide, architecture layer label,
  connectors slide title, abstraction advantage body, By the Numbers stat,
  closing summary line
- GNAT-Presentation.pptx: rebuilt with corrected count

https://claude.ai/code/session_01BDoue9HxB83ijLzFARAugq
</commit_message>
<xml_diff>
--- a/GNAT-Presentation.pptx
+++ b/GNAT-Presentation.pptx
@@ -8983,7 +8983,7 @@
                 <a:ea typeface="Calibri" pitchFamily="34" charset="-122"/>
                 <a:cs typeface="Calibri" pitchFamily="34" charset="-120"/>
               </a:rPr>
-              <a:t>API changes affect one connector file, not every script. Tests cover all 26 connectors uniformly. One library version number covers the entire integration stack.</a:t>
+              <a:t>API changes affect one connector file, not every script. Tests cover all 29 connectors uniformly. One library version number covers the entire integration stack.</a:t>
             </a:r>
             <a:endParaRPr lang="en-US" sz="950" dirty="0"/>
           </a:p>
@@ -11008,7 +11008,7 @@
                 <a:ea typeface="Calibri" pitchFamily="34" charset="-122"/>
                 <a:cs typeface="Calibri" pitchFamily="34" charset="-120"/>
               </a:rPr>
-              <a:t>26</a:t>
+              <a:t>29</a:t>
             </a:r>
             <a:endParaRPr lang="en-US" sz="4400" dirty="0"/>
           </a:p>
@@ -14347,7 +14347,7 @@
                 <a:ea typeface="Calibri" pitchFamily="34" charset="-122"/>
                 <a:cs typeface="Calibri" pitchFamily="34" charset="-120"/>
               </a:rPr>
-              <a:t>26 connectors · STIX 2.1 · Ingest + Export pipelines</a:t>
+              <a:t>29 connectors · STIX 2.1 · Ingest + Export pipelines</a:t>
             </a:r>
             <a:endParaRPr lang="en-US" sz="1400" dirty="0"/>
           </a:p>
@@ -14701,7 +14701,7 @@
                 <a:ea typeface="Calibri" pitchFamily="34" charset="-122"/>
                 <a:cs typeface="Calibri" pitchFamily="34" charset="-120"/>
               </a:rPr>
-              <a:t>26 Different APIs</a:t>
+              <a:t>29 Different APIs</a:t>
             </a:r>
             <a:endParaRPr lang="en-US" sz="1200" dirty="0"/>
           </a:p>
@@ -16355,7 +16355,7 @@
                 <a:ea typeface="Calibri" pitchFamily="34" charset="-122"/>
                 <a:cs typeface="Calibri" pitchFamily="34" charset="-120"/>
               </a:rPr>
-              <a:t>CONNECTOR LAYER (26 platforms)</a:t>
+              <a:t>CONNECTOR LAYER (29 platforms)</a:t>
             </a:r>
             <a:endParaRPr lang="en-US" sz="1000" dirty="0"/>
           </a:p>
@@ -16681,7 +16681,7 @@
                 <a:ea typeface="Calibri" pitchFamily="34" charset="-122"/>
                 <a:cs typeface="Calibri" pitchFamily="34" charset="-120"/>
               </a:rPr>
-              <a:t>26 Platform Connectors — One Interface</a:t>
+              <a:t>29 Platform Connectors — One Interface</a:t>
             </a:r>
             <a:endParaRPr lang="en-US" sz="2000" dirty="0"/>
           </a:p>

</xml_diff>

<commit_message>
Update connector count to 95, remove artifact arrows from slides 7/11/12/25, rebuild PPTX
Agent-Logs-Url: https://github.com/wrhalpin/GNAT/sessions/66d9becc-8fc6-4605-8a89-b79c62e75eb2

Co-authored-by: wrhalpin <194402614+wrhalpin@users.noreply.github.com>
</commit_message>
<xml_diff>
--- a/GNAT-Presentation.pptx
+++ b/GNAT-Presentation.pptx
@@ -3375,7 +3375,7 @@
                 <a:ea typeface="Calibri" pitchFamily="34" charset="-122"/>
                 <a:cs typeface="Calibri" pitchFamily="34" charset="-120"/>
               </a:rPr>
-              <a:t>60+ Connectors</a:t>
+              <a:t>95 Connectors</a:t>
             </a:r>
             <a:endParaRPr lang="en-US" sz="1000" dirty="0"/>
           </a:p>
@@ -3709,7 +3709,7 @@
                 <a:ea typeface="Calibri" pitchFamily="34" charset="-122"/>
                 <a:cs typeface="Calibri" pitchFamily="34" charset="-120"/>
               </a:rPr>
-              <a:t>Version 1.1  ·  Python 3.9+  ·  STIX 2.1  ·  60+ Platform Connectors  ·  1,500+ Tests</a:t>
+              <a:t>Version 1.1  ·  Python 3.9+  ·  STIX 2.1  ·  95 Platform Connectors  ·  1,500+ Tests</a:t>
             </a:r>
             <a:endParaRPr lang="en-US" sz="1000" dirty="0"/>
           </a:p>
@@ -4888,30 +4888,6 @@
         </p:nvSpPr>
         <p:spPr>
           <a:xfrm>
-            <a:off x="2468880" y="1645920"/>
-            <a:ext cx="0" cy="182880"/>
-          </a:xfrm>
-          <a:prstGeom prst="line">
-            <a:avLst/>
-          </a:prstGeom>
-          <a:noFill/>
-          <a:ln w="25400">
-            <a:solidFill>
-              <a:srgbClr val="06B6D4"/>
-            </a:solidFill>
-            <a:prstDash val="solid"/>
-            <a:tailEnd type="triangle"/>
-          </a:ln>
-        </p:spPr>
-      </p:sp>
-      <p:sp>
-        <p:nvSpPr>
-          <p:cNvPr id="9" name="Shape 7"/>
-          <p:cNvSpPr/>
-          <p:nvPr/>
-        </p:nvSpPr>
-        <p:spPr>
-          <a:xfrm>
             <a:off x="320040" y="1828800"/>
             <a:ext cx="5029200" cy="777240"/>
           </a:xfrm>
@@ -4931,7 +4907,7 @@
       </p:sp>
       <p:sp>
         <p:nvSpPr>
-          <p:cNvPr id="10" name="Text 8"/>
+          <p:cNvPr id="9" name="Text 7"/>
           <p:cNvSpPr/>
           <p:nvPr/>
         </p:nvSpPr>
@@ -4970,7 +4946,7 @@
       </p:sp>
       <p:sp>
         <p:nvSpPr>
-          <p:cNvPr id="11" name="Text 9"/>
+          <p:cNvPr id="10" name="Text 8"/>
           <p:cNvSpPr/>
           <p:nvPr/>
         </p:nvSpPr>
@@ -5009,31 +4985,7 @@
       </p:sp>
       <p:sp>
         <p:nvSpPr>
-          <p:cNvPr id="12" name="Shape 10"/>
-          <p:cNvSpPr/>
-          <p:nvPr/>
-        </p:nvSpPr>
-        <p:spPr>
-          <a:xfrm>
-            <a:off x="2468880" y="2606040"/>
-            <a:ext cx="0" cy="182880"/>
-          </a:xfrm>
-          <a:prstGeom prst="line">
-            <a:avLst/>
-          </a:prstGeom>
-          <a:noFill/>
-          <a:ln w="25400">
-            <a:solidFill>
-              <a:srgbClr val="06B6D4"/>
-            </a:solidFill>
-            <a:prstDash val="solid"/>
-            <a:tailEnd type="triangle"/>
-          </a:ln>
-        </p:spPr>
-      </p:sp>
-      <p:sp>
-        <p:nvSpPr>
-          <p:cNvPr id="13" name="Shape 11"/>
+          <p:cNvPr id="11" name="Shape 9"/>
           <p:cNvSpPr/>
           <p:nvPr/>
         </p:nvSpPr>
@@ -5058,7 +5010,7 @@
       </p:sp>
       <p:sp>
         <p:nvSpPr>
-          <p:cNvPr id="14" name="Text 12"/>
+          <p:cNvPr id="12" name="Text 10"/>
           <p:cNvSpPr/>
           <p:nvPr/>
         </p:nvSpPr>
@@ -5097,7 +5049,7 @@
       </p:sp>
       <p:sp>
         <p:nvSpPr>
-          <p:cNvPr id="15" name="Text 13"/>
+          <p:cNvPr id="13" name="Text 11"/>
           <p:cNvSpPr/>
           <p:nvPr/>
         </p:nvSpPr>
@@ -5136,7 +5088,7 @@
       </p:sp>
       <p:sp>
         <p:nvSpPr>
-          <p:cNvPr id="16" name="Text 14"/>
+          <p:cNvPr id="14" name="Text 12"/>
           <p:cNvSpPr/>
           <p:nvPr/>
         </p:nvSpPr>
@@ -6442,7 +6394,7 @@
       </p:graphicFrame>
       <p:sp>
         <p:nvSpPr>
-          <p:cNvPr id="18" name="Text 15"/>
+          <p:cNvPr id="16" name="Text 13"/>
           <p:cNvSpPr/>
           <p:nvPr/>
         </p:nvSpPr>
@@ -7954,30 +7906,6 @@
         </p:nvSpPr>
         <p:spPr>
           <a:xfrm>
-            <a:off x="2221992" y="4160520"/>
-            <a:ext cx="219456" cy="0"/>
-          </a:xfrm>
-          <a:prstGeom prst="line">
-            <a:avLst/>
-          </a:prstGeom>
-          <a:noFill/>
-          <a:ln w="19050">
-            <a:solidFill>
-              <a:srgbClr val="06B6D4"/>
-            </a:solidFill>
-            <a:prstDash val="solid"/>
-            <a:tailEnd type="triangle"/>
-          </a:ln>
-        </p:spPr>
-      </p:sp>
-      <p:sp>
-        <p:nvSpPr>
-          <p:cNvPr id="42" name="Shape 40"/>
-          <p:cNvSpPr/>
-          <p:nvPr/>
-        </p:nvSpPr>
-        <p:spPr>
-          <a:xfrm>
             <a:off x="2468880" y="3794760"/>
             <a:ext cx="1874520" cy="731520"/>
           </a:xfrm>
@@ -7997,7 +7925,7 @@
       </p:sp>
       <p:sp>
         <p:nvSpPr>
-          <p:cNvPr id="43" name="Text 41"/>
+          <p:cNvPr id="42" name="Text 40"/>
           <p:cNvSpPr/>
           <p:nvPr/>
         </p:nvSpPr>
@@ -8053,31 +7981,7 @@
       </p:sp>
       <p:sp>
         <p:nvSpPr>
-          <p:cNvPr id="44" name="Shape 42"/>
-          <p:cNvSpPr/>
-          <p:nvPr/>
-        </p:nvSpPr>
-        <p:spPr>
-          <a:xfrm>
-            <a:off x="4370832" y="4160520"/>
-            <a:ext cx="219456" cy="0"/>
-          </a:xfrm>
-          <a:prstGeom prst="line">
-            <a:avLst/>
-          </a:prstGeom>
-          <a:noFill/>
-          <a:ln w="19050">
-            <a:solidFill>
-              <a:srgbClr val="06B6D4"/>
-            </a:solidFill>
-            <a:prstDash val="solid"/>
-            <a:tailEnd type="triangle"/>
-          </a:ln>
-        </p:spPr>
-      </p:sp>
-      <p:sp>
-        <p:nvSpPr>
-          <p:cNvPr id="45" name="Shape 43"/>
+          <p:cNvPr id="43" name="Shape 41"/>
           <p:cNvSpPr/>
           <p:nvPr/>
         </p:nvSpPr>
@@ -8102,7 +8006,7 @@
       </p:sp>
       <p:sp>
         <p:nvSpPr>
-          <p:cNvPr id="46" name="Text 44"/>
+          <p:cNvPr id="44" name="Text 42"/>
           <p:cNvSpPr/>
           <p:nvPr/>
         </p:nvSpPr>
@@ -8158,31 +8062,7 @@
       </p:sp>
       <p:sp>
         <p:nvSpPr>
-          <p:cNvPr id="47" name="Shape 45"/>
-          <p:cNvSpPr/>
-          <p:nvPr/>
-        </p:nvSpPr>
-        <p:spPr>
-          <a:xfrm>
-            <a:off x="6519672" y="4160520"/>
-            <a:ext cx="219456" cy="0"/>
-          </a:xfrm>
-          <a:prstGeom prst="line">
-            <a:avLst/>
-          </a:prstGeom>
-          <a:noFill/>
-          <a:ln w="19050">
-            <a:solidFill>
-              <a:srgbClr val="06B6D4"/>
-            </a:solidFill>
-            <a:prstDash val="solid"/>
-            <a:tailEnd type="triangle"/>
-          </a:ln>
-        </p:spPr>
-      </p:sp>
-      <p:sp>
-        <p:nvSpPr>
-          <p:cNvPr id="48" name="Shape 46"/>
+          <p:cNvPr id="45" name="Shape 43"/>
           <p:cNvSpPr/>
           <p:nvPr/>
         </p:nvSpPr>
@@ -8207,7 +8087,7 @@
       </p:sp>
       <p:sp>
         <p:nvSpPr>
-          <p:cNvPr id="49" name="Text 47"/>
+          <p:cNvPr id="46" name="Text 44"/>
           <p:cNvSpPr/>
           <p:nvPr/>
         </p:nvSpPr>
@@ -19069,7 +18949,7 @@
                 <a:ea typeface="Calibri" pitchFamily="34" charset="-122"/>
                 <a:cs typeface="Calibri" pitchFamily="34" charset="-120"/>
               </a:rPr>
-              <a:t>Every platform exposes get_object(), list_objects(), upsert_object(), to_stix(), from_stix(). Analysts learn one mental model once and it works across 60+ platforms.</a:t>
+              <a:t>Every platform exposes get_object(), list_objects(), upsert_object(), to_stix(), from_stix(). Analysts learn one mental model once and it works across 95 platforms.</a:t>
             </a:r>
             <a:endParaRPr lang="en-US" sz="950" dirty="0"/>
           </a:p>
@@ -20992,7 +20872,7 @@
                 <a:ea typeface="Calibri" pitchFamily="34" charset="-122"/>
                 <a:cs typeface="Calibri" pitchFamily="34" charset="-120"/>
               </a:rPr>
-              <a:t>60+</a:t>
+              <a:t>95</a:t>
             </a:r>
             <a:endParaRPr lang="en-US" sz="4200" dirty="0"/>
           </a:p>
@@ -22186,30 +22066,6 @@
         </p:nvSpPr>
         <p:spPr>
           <a:xfrm>
-            <a:off x="1673352" y="1069848"/>
-            <a:ext cx="91440" cy="0"/>
-          </a:xfrm>
-          <a:prstGeom prst="line">
-            <a:avLst/>
-          </a:prstGeom>
-          <a:noFill/>
-          <a:ln w="12700">
-            <a:solidFill>
-              <a:srgbClr val="1E4D8C"/>
-            </a:solidFill>
-            <a:prstDash val="solid"/>
-            <a:tailEnd type="triangle"/>
-          </a:ln>
-        </p:spPr>
-      </p:sp>
-      <p:sp>
-        <p:nvSpPr>
-          <p:cNvPr id="12" name="Shape 10"/>
-          <p:cNvSpPr/>
-          <p:nvPr/>
-        </p:nvSpPr>
-        <p:spPr>
-          <a:xfrm>
             <a:off x="1783080" y="822960"/>
             <a:ext cx="1325880" cy="502920"/>
           </a:xfrm>
@@ -22229,7 +22085,7 @@
       </p:sp>
       <p:sp>
         <p:nvSpPr>
-          <p:cNvPr id="13" name="Text 11"/>
+          <p:cNvPr id="12" name="Text 10"/>
           <p:cNvSpPr/>
           <p:nvPr/>
         </p:nvSpPr>
@@ -22268,7 +22124,7 @@
       </p:sp>
       <p:sp>
         <p:nvSpPr>
-          <p:cNvPr id="14" name="Text 12"/>
+          <p:cNvPr id="13" name="Text 11"/>
           <p:cNvSpPr/>
           <p:nvPr/>
         </p:nvSpPr>
@@ -22307,7 +22163,7 @@
       </p:sp>
       <p:sp>
         <p:nvSpPr>
-          <p:cNvPr id="15" name="Shape 13"/>
+          <p:cNvPr id="14" name="Shape 12"/>
           <p:cNvSpPr/>
           <p:nvPr/>
         </p:nvSpPr>
@@ -22332,7 +22188,7 @@
       </p:sp>
       <p:sp>
         <p:nvSpPr>
-          <p:cNvPr id="16" name="Text 14"/>
+          <p:cNvPr id="15" name="Text 13"/>
           <p:cNvSpPr/>
           <p:nvPr/>
         </p:nvSpPr>
@@ -22371,7 +22227,7 @@
       </p:sp>
       <p:sp>
         <p:nvSpPr>
-          <p:cNvPr id="17" name="Text 15"/>
+          <p:cNvPr id="16" name="Text 14"/>
           <p:cNvSpPr/>
           <p:nvPr/>
         </p:nvSpPr>
@@ -22447,31 +22303,7 @@
       </p:sp>
       <p:sp>
         <p:nvSpPr>
-          <p:cNvPr id="18" name="Shape 16"/>
-          <p:cNvSpPr/>
-          <p:nvPr/>
-        </p:nvSpPr>
-        <p:spPr>
-          <a:xfrm>
-            <a:off x="3136392" y="1069848"/>
-            <a:ext cx="91440" cy="0"/>
-          </a:xfrm>
-          <a:prstGeom prst="line">
-            <a:avLst/>
-          </a:prstGeom>
-          <a:noFill/>
-          <a:ln w="12700">
-            <a:solidFill>
-              <a:srgbClr val="1E4D8C"/>
-            </a:solidFill>
-            <a:prstDash val="solid"/>
-            <a:tailEnd type="triangle"/>
-          </a:ln>
-        </p:spPr>
-      </p:sp>
-      <p:sp>
-        <p:nvSpPr>
-          <p:cNvPr id="19" name="Shape 17"/>
+          <p:cNvPr id="17" name="Shape 15"/>
           <p:cNvSpPr/>
           <p:nvPr/>
         </p:nvSpPr>
@@ -22496,7 +22328,7 @@
       </p:sp>
       <p:sp>
         <p:nvSpPr>
-          <p:cNvPr id="20" name="Text 18"/>
+          <p:cNvPr id="18" name="Text 16"/>
           <p:cNvSpPr/>
           <p:nvPr/>
         </p:nvSpPr>
@@ -22535,7 +22367,7 @@
       </p:sp>
       <p:sp>
         <p:nvSpPr>
-          <p:cNvPr id="21" name="Text 19"/>
+          <p:cNvPr id="19" name="Text 17"/>
           <p:cNvSpPr/>
           <p:nvPr/>
         </p:nvSpPr>
@@ -22574,7 +22406,7 @@
       </p:sp>
       <p:sp>
         <p:nvSpPr>
-          <p:cNvPr id="22" name="Shape 20"/>
+          <p:cNvPr id="20" name="Shape 18"/>
           <p:cNvSpPr/>
           <p:nvPr/>
         </p:nvSpPr>
@@ -22599,7 +22431,7 @@
       </p:sp>
       <p:sp>
         <p:nvSpPr>
-          <p:cNvPr id="23" name="Text 21"/>
+          <p:cNvPr id="21" name="Text 19"/>
           <p:cNvSpPr/>
           <p:nvPr/>
         </p:nvSpPr>
@@ -22638,7 +22470,7 @@
       </p:sp>
       <p:sp>
         <p:nvSpPr>
-          <p:cNvPr id="24" name="Text 22"/>
+          <p:cNvPr id="22" name="Text 20"/>
           <p:cNvSpPr/>
           <p:nvPr/>
         </p:nvSpPr>
@@ -22714,31 +22546,7 @@
       </p:sp>
       <p:sp>
         <p:nvSpPr>
-          <p:cNvPr id="25" name="Shape 23"/>
-          <p:cNvSpPr/>
-          <p:nvPr/>
-        </p:nvSpPr>
-        <p:spPr>
-          <a:xfrm>
-            <a:off x="4599432" y="1069848"/>
-            <a:ext cx="91440" cy="0"/>
-          </a:xfrm>
-          <a:prstGeom prst="line">
-            <a:avLst/>
-          </a:prstGeom>
-          <a:noFill/>
-          <a:ln w="12700">
-            <a:solidFill>
-              <a:srgbClr val="1E4D8C"/>
-            </a:solidFill>
-            <a:prstDash val="solid"/>
-            <a:tailEnd type="triangle"/>
-          </a:ln>
-        </p:spPr>
-      </p:sp>
-      <p:sp>
-        <p:nvSpPr>
-          <p:cNvPr id="26" name="Shape 24"/>
+          <p:cNvPr id="23" name="Shape 21"/>
           <p:cNvSpPr/>
           <p:nvPr/>
         </p:nvSpPr>
@@ -22763,7 +22571,7 @@
       </p:sp>
       <p:sp>
         <p:nvSpPr>
-          <p:cNvPr id="27" name="Text 25"/>
+          <p:cNvPr id="24" name="Text 22"/>
           <p:cNvSpPr/>
           <p:nvPr/>
         </p:nvSpPr>
@@ -22802,7 +22610,7 @@
       </p:sp>
       <p:sp>
         <p:nvSpPr>
-          <p:cNvPr id="28" name="Text 26"/>
+          <p:cNvPr id="25" name="Text 23"/>
           <p:cNvSpPr/>
           <p:nvPr/>
         </p:nvSpPr>
@@ -22841,7 +22649,7 @@
       </p:sp>
       <p:sp>
         <p:nvSpPr>
-          <p:cNvPr id="29" name="Shape 27"/>
+          <p:cNvPr id="26" name="Shape 24"/>
           <p:cNvSpPr/>
           <p:nvPr/>
         </p:nvSpPr>
@@ -22866,7 +22674,7 @@
       </p:sp>
       <p:sp>
         <p:nvSpPr>
-          <p:cNvPr id="30" name="Text 28"/>
+          <p:cNvPr id="27" name="Text 25"/>
           <p:cNvSpPr/>
           <p:nvPr/>
         </p:nvSpPr>
@@ -22905,7 +22713,7 @@
       </p:sp>
       <p:sp>
         <p:nvSpPr>
-          <p:cNvPr id="31" name="Text 29"/>
+          <p:cNvPr id="28" name="Text 26"/>
           <p:cNvSpPr/>
           <p:nvPr/>
         </p:nvSpPr>
@@ -22981,31 +22789,7 @@
       </p:sp>
       <p:sp>
         <p:nvSpPr>
-          <p:cNvPr id="32" name="Shape 30"/>
-          <p:cNvSpPr/>
-          <p:nvPr/>
-        </p:nvSpPr>
-        <p:spPr>
-          <a:xfrm>
-            <a:off x="6062472" y="1069848"/>
-            <a:ext cx="91440" cy="0"/>
-          </a:xfrm>
-          <a:prstGeom prst="line">
-            <a:avLst/>
-          </a:prstGeom>
-          <a:noFill/>
-          <a:ln w="12700">
-            <a:solidFill>
-              <a:srgbClr val="1E4D8C"/>
-            </a:solidFill>
-            <a:prstDash val="solid"/>
-            <a:tailEnd type="triangle"/>
-          </a:ln>
-        </p:spPr>
-      </p:sp>
-      <p:sp>
-        <p:nvSpPr>
-          <p:cNvPr id="33" name="Shape 31"/>
+          <p:cNvPr id="29" name="Shape 27"/>
           <p:cNvSpPr/>
           <p:nvPr/>
         </p:nvSpPr>
@@ -23030,7 +22814,7 @@
       </p:sp>
       <p:sp>
         <p:nvSpPr>
-          <p:cNvPr id="34" name="Text 32"/>
+          <p:cNvPr id="30" name="Text 28"/>
           <p:cNvSpPr/>
           <p:nvPr/>
         </p:nvSpPr>
@@ -23069,7 +22853,7 @@
       </p:sp>
       <p:sp>
         <p:nvSpPr>
-          <p:cNvPr id="35" name="Text 33"/>
+          <p:cNvPr id="31" name="Text 29"/>
           <p:cNvSpPr/>
           <p:nvPr/>
         </p:nvSpPr>
@@ -23108,7 +22892,7 @@
       </p:sp>
       <p:sp>
         <p:nvSpPr>
-          <p:cNvPr id="36" name="Shape 34"/>
+          <p:cNvPr id="32" name="Shape 30"/>
           <p:cNvSpPr/>
           <p:nvPr/>
         </p:nvSpPr>
@@ -23133,7 +22917,7 @@
       </p:sp>
       <p:sp>
         <p:nvSpPr>
-          <p:cNvPr id="37" name="Text 35"/>
+          <p:cNvPr id="33" name="Text 31"/>
           <p:cNvSpPr/>
           <p:nvPr/>
         </p:nvSpPr>
@@ -23172,7 +22956,7 @@
       </p:sp>
       <p:sp>
         <p:nvSpPr>
-          <p:cNvPr id="38" name="Text 36"/>
+          <p:cNvPr id="34" name="Text 32"/>
           <p:cNvSpPr/>
           <p:nvPr/>
         </p:nvSpPr>
@@ -23248,31 +23032,7 @@
       </p:sp>
       <p:sp>
         <p:nvSpPr>
-          <p:cNvPr id="39" name="Shape 37"/>
-          <p:cNvSpPr/>
-          <p:nvPr/>
-        </p:nvSpPr>
-        <p:spPr>
-          <a:xfrm>
-            <a:off x="7525512" y="1069848"/>
-            <a:ext cx="91440" cy="0"/>
-          </a:xfrm>
-          <a:prstGeom prst="line">
-            <a:avLst/>
-          </a:prstGeom>
-          <a:noFill/>
-          <a:ln w="12700">
-            <a:solidFill>
-              <a:srgbClr val="1E4D8C"/>
-            </a:solidFill>
-            <a:prstDash val="solid"/>
-            <a:tailEnd type="triangle"/>
-          </a:ln>
-        </p:spPr>
-      </p:sp>
-      <p:sp>
-        <p:nvSpPr>
-          <p:cNvPr id="40" name="Shape 38"/>
+          <p:cNvPr id="35" name="Shape 33"/>
           <p:cNvSpPr/>
           <p:nvPr/>
         </p:nvSpPr>
@@ -23297,7 +23057,7 @@
       </p:sp>
       <p:sp>
         <p:nvSpPr>
-          <p:cNvPr id="41" name="Text 39"/>
+          <p:cNvPr id="36" name="Text 34"/>
           <p:cNvSpPr/>
           <p:nvPr/>
         </p:nvSpPr>
@@ -23336,7 +23096,7 @@
       </p:sp>
       <p:sp>
         <p:nvSpPr>
-          <p:cNvPr id="42" name="Text 40"/>
+          <p:cNvPr id="37" name="Text 35"/>
           <p:cNvSpPr/>
           <p:nvPr/>
         </p:nvSpPr>
@@ -23375,7 +23135,7 @@
       </p:sp>
       <p:sp>
         <p:nvSpPr>
-          <p:cNvPr id="43" name="Shape 41"/>
+          <p:cNvPr id="38" name="Shape 36"/>
           <p:cNvSpPr/>
           <p:nvPr/>
         </p:nvSpPr>
@@ -23400,7 +23160,7 @@
       </p:sp>
       <p:sp>
         <p:nvSpPr>
-          <p:cNvPr id="44" name="Text 42"/>
+          <p:cNvPr id="39" name="Text 37"/>
           <p:cNvSpPr/>
           <p:nvPr/>
         </p:nvSpPr>
@@ -23439,7 +23199,7 @@
       </p:sp>
       <p:sp>
         <p:nvSpPr>
-          <p:cNvPr id="45" name="Text 43"/>
+          <p:cNvPr id="40" name="Text 38"/>
           <p:cNvSpPr/>
           <p:nvPr/>
         </p:nvSpPr>
@@ -26139,7 +25899,7 @@
                 <a:ea typeface="Calibri" pitchFamily="34" charset="-122"/>
                 <a:cs typeface="Calibri" pitchFamily="34" charset="-120"/>
               </a:rPr>
-              <a:t>60+ connectors total in CLIENT_REGISTRY</a:t>
+              <a:t>95 connectors total in CLIENT_REGISTRY</a:t>
             </a:r>
             <a:endParaRPr lang="en-US" sz="850" dirty="0"/>
           </a:p>
@@ -26584,7 +26344,7 @@
                 <a:ea typeface="Calibri" pitchFamily="34" charset="-122"/>
                 <a:cs typeface="Calibri" pitchFamily="34" charset="-120"/>
               </a:rPr>
-              <a:t>60+ connectors · STIX 2.1 ORM · Ingest + Export pipelines</a:t>
+              <a:t>95 connectors · STIX 2.1 ORM · Ingest + Export pipelines</a:t>
             </a:r>
             <a:endParaRPr lang="en-US" sz="1300" dirty="0"/>
           </a:p>
@@ -27910,7 +27670,7 @@
                 <a:ea typeface="Calibri" pitchFamily="34" charset="-122"/>
                 <a:cs typeface="Calibri" pitchFamily="34" charset="-120"/>
               </a:rPr>
-              <a:t>CONNECTOR LAYER (60+ platforms)</a:t>
+              <a:t>CONNECTOR LAYER (95 platforms)</a:t>
             </a:r>
             <a:endParaRPr lang="en-US" sz="1000" dirty="0"/>
           </a:p>
@@ -28236,7 +27996,7 @@
                 <a:ea typeface="Calibri" pitchFamily="34" charset="-122"/>
                 <a:cs typeface="Calibri" pitchFamily="34" charset="-120"/>
               </a:rPr>
-              <a:t>60+ Platform Connectors — One Interface</a:t>
+              <a:t>95 Platform Connectors — One Interface</a:t>
             </a:r>
             <a:endParaRPr lang="en-US" sz="2000" dirty="0"/>
           </a:p>
@@ -30770,30 +30530,6 @@
         </p:nvSpPr>
         <p:spPr>
           <a:xfrm>
-            <a:off x="1581912" y="2075688"/>
-            <a:ext cx="109728" cy="0"/>
-          </a:xfrm>
-          <a:prstGeom prst="line">
-            <a:avLst/>
-          </a:prstGeom>
-          <a:noFill/>
-          <a:ln w="19050">
-            <a:solidFill>
-              <a:srgbClr val="0891B2"/>
-            </a:solidFill>
-            <a:prstDash val="solid"/>
-            <a:tailEnd type="triangle"/>
-          </a:ln>
-        </p:spPr>
-      </p:sp>
-      <p:sp>
-        <p:nvSpPr>
-          <p:cNvPr id="11" name="Shape 9"/>
-          <p:cNvSpPr/>
-          <p:nvPr/>
-        </p:nvSpPr>
-        <p:spPr>
-          <a:xfrm>
             <a:off x="1691640" y="1234440"/>
             <a:ext cx="1234440" cy="1691640"/>
           </a:xfrm>
@@ -30820,7 +30556,7 @@
       </p:sp>
       <p:sp>
         <p:nvSpPr>
-          <p:cNvPr id="12" name="Text 10"/>
+          <p:cNvPr id="11" name="Text 9"/>
           <p:cNvSpPr/>
           <p:nvPr/>
         </p:nvSpPr>
@@ -30859,7 +30595,7 @@
       </p:sp>
       <p:sp>
         <p:nvSpPr>
-          <p:cNvPr id="13" name="Text 11"/>
+          <p:cNvPr id="12" name="Text 10"/>
           <p:cNvSpPr/>
           <p:nvPr/>
         </p:nvSpPr>
@@ -30932,31 +30668,7 @@
       </p:sp>
       <p:sp>
         <p:nvSpPr>
-          <p:cNvPr id="14" name="Shape 12"/>
-          <p:cNvSpPr/>
-          <p:nvPr/>
-        </p:nvSpPr>
-        <p:spPr>
-          <a:xfrm>
-            <a:off x="2953512" y="2075688"/>
-            <a:ext cx="109728" cy="0"/>
-          </a:xfrm>
-          <a:prstGeom prst="line">
-            <a:avLst/>
-          </a:prstGeom>
-          <a:noFill/>
-          <a:ln w="19050">
-            <a:solidFill>
-              <a:srgbClr val="0891B2"/>
-            </a:solidFill>
-            <a:prstDash val="solid"/>
-            <a:tailEnd type="triangle"/>
-          </a:ln>
-        </p:spPr>
-      </p:sp>
-      <p:sp>
-        <p:nvSpPr>
-          <p:cNvPr id="15" name="Shape 13"/>
+          <p:cNvPr id="13" name="Shape 11"/>
           <p:cNvSpPr/>
           <p:nvPr/>
         </p:nvSpPr>
@@ -30988,7 +30700,7 @@
       </p:sp>
       <p:sp>
         <p:nvSpPr>
-          <p:cNvPr id="16" name="Text 14"/>
+          <p:cNvPr id="14" name="Text 12"/>
           <p:cNvSpPr/>
           <p:nvPr/>
         </p:nvSpPr>
@@ -31027,7 +30739,7 @@
       </p:sp>
       <p:sp>
         <p:nvSpPr>
-          <p:cNvPr id="17" name="Text 15"/>
+          <p:cNvPr id="15" name="Text 13"/>
           <p:cNvSpPr/>
           <p:nvPr/>
         </p:nvSpPr>
@@ -31100,7 +30812,7 @@
       </p:sp>
       <p:sp>
         <p:nvSpPr>
-          <p:cNvPr id="18" name="Shape 16"/>
+          <p:cNvPr id="16" name="Shape 14"/>
           <p:cNvSpPr/>
           <p:nvPr/>
         </p:nvSpPr>
@@ -31125,7 +30837,7 @@
       </p:sp>
       <p:sp>
         <p:nvSpPr>
-          <p:cNvPr id="19" name="Text 17"/>
+          <p:cNvPr id="17" name="Text 15"/>
           <p:cNvSpPr/>
           <p:nvPr/>
         </p:nvSpPr>
@@ -31164,7 +30876,7 @@
       </p:sp>
       <p:sp>
         <p:nvSpPr>
-          <p:cNvPr id="20" name="Shape 18"/>
+          <p:cNvPr id="18" name="Shape 16"/>
           <p:cNvSpPr/>
           <p:nvPr/>
         </p:nvSpPr>
@@ -31196,7 +30908,7 @@
       </p:sp>
       <p:sp>
         <p:nvSpPr>
-          <p:cNvPr id="21" name="Text 19"/>
+          <p:cNvPr id="19" name="Text 17"/>
           <p:cNvSpPr/>
           <p:nvPr/>
         </p:nvSpPr>
@@ -31235,7 +30947,7 @@
       </p:sp>
       <p:sp>
         <p:nvSpPr>
-          <p:cNvPr id="22" name="Text 20"/>
+          <p:cNvPr id="20" name="Text 18"/>
           <p:cNvSpPr/>
           <p:nvPr/>
         </p:nvSpPr>
@@ -31308,31 +31020,7 @@
       </p:sp>
       <p:sp>
         <p:nvSpPr>
-          <p:cNvPr id="23" name="Shape 21"/>
-          <p:cNvSpPr/>
-          <p:nvPr/>
-        </p:nvSpPr>
-        <p:spPr>
-          <a:xfrm>
-            <a:off x="6062472" y="2075688"/>
-            <a:ext cx="109728" cy="0"/>
-          </a:xfrm>
-          <a:prstGeom prst="line">
-            <a:avLst/>
-          </a:prstGeom>
-          <a:noFill/>
-          <a:ln w="19050">
-            <a:solidFill>
-              <a:srgbClr val="0891B2"/>
-            </a:solidFill>
-            <a:prstDash val="solid"/>
-            <a:tailEnd type="triangle"/>
-          </a:ln>
-        </p:spPr>
-      </p:sp>
-      <p:sp>
-        <p:nvSpPr>
-          <p:cNvPr id="24" name="Shape 22"/>
+          <p:cNvPr id="21" name="Shape 19"/>
           <p:cNvSpPr/>
           <p:nvPr/>
         </p:nvSpPr>
@@ -31364,7 +31052,7 @@
       </p:sp>
       <p:sp>
         <p:nvSpPr>
-          <p:cNvPr id="25" name="Text 23"/>
+          <p:cNvPr id="22" name="Text 20"/>
           <p:cNvSpPr/>
           <p:nvPr/>
         </p:nvSpPr>
@@ -31403,7 +31091,7 @@
       </p:sp>
       <p:sp>
         <p:nvSpPr>
-          <p:cNvPr id="26" name="Text 24"/>
+          <p:cNvPr id="23" name="Text 21"/>
           <p:cNvSpPr/>
           <p:nvPr/>
         </p:nvSpPr>
@@ -31476,31 +31164,7 @@
       </p:sp>
       <p:sp>
         <p:nvSpPr>
-          <p:cNvPr id="27" name="Shape 25"/>
-          <p:cNvSpPr/>
-          <p:nvPr/>
-        </p:nvSpPr>
-        <p:spPr>
-          <a:xfrm>
-            <a:off x="7434072" y="2075688"/>
-            <a:ext cx="109728" cy="0"/>
-          </a:xfrm>
-          <a:prstGeom prst="line">
-            <a:avLst/>
-          </a:prstGeom>
-          <a:noFill/>
-          <a:ln w="19050">
-            <a:solidFill>
-              <a:srgbClr val="0891B2"/>
-            </a:solidFill>
-            <a:prstDash val="solid"/>
-            <a:tailEnd type="triangle"/>
-          </a:ln>
-        </p:spPr>
-      </p:sp>
-      <p:sp>
-        <p:nvSpPr>
-          <p:cNvPr id="28" name="Shape 26"/>
+          <p:cNvPr id="24" name="Shape 22"/>
           <p:cNvSpPr/>
           <p:nvPr/>
         </p:nvSpPr>
@@ -31532,7 +31196,7 @@
       </p:sp>
       <p:sp>
         <p:nvSpPr>
-          <p:cNvPr id="29" name="Text 27"/>
+          <p:cNvPr id="25" name="Text 23"/>
           <p:cNvSpPr/>
           <p:nvPr/>
         </p:nvSpPr>
@@ -31571,7 +31235,7 @@
       </p:sp>
       <p:sp>
         <p:nvSpPr>
-          <p:cNvPr id="30" name="Text 28"/>
+          <p:cNvPr id="26" name="Text 24"/>
           <p:cNvSpPr/>
           <p:nvPr/>
         </p:nvSpPr>
@@ -31661,7 +31325,7 @@
       </p:sp>
       <p:sp>
         <p:nvSpPr>
-          <p:cNvPr id="31" name="Text 29"/>
+          <p:cNvPr id="27" name="Text 25"/>
           <p:cNvSpPr/>
           <p:nvPr/>
         </p:nvSpPr>
@@ -31700,7 +31364,7 @@
       </p:sp>
       <p:sp>
         <p:nvSpPr>
-          <p:cNvPr id="32" name="Shape 30"/>
+          <p:cNvPr id="28" name="Shape 26"/>
           <p:cNvSpPr/>
           <p:nvPr/>
         </p:nvSpPr>
@@ -31725,7 +31389,7 @@
       </p:sp>
       <p:sp>
         <p:nvSpPr>
-          <p:cNvPr id="33" name="Text 31"/>
+          <p:cNvPr id="29" name="Text 27"/>
           <p:cNvSpPr/>
           <p:nvPr/>
         </p:nvSpPr>

</xml_diff>

<commit_message>
Fix presentation: contrast colors on slides 5/6, restore arrows on slides 11/12, rebuild deck
Agent-Logs-Url: https://github.com/wrhalpin/GNAT/sessions/bd9c463f-34da-4b66-ac6b-3950794537b4

Co-authored-by: wrhalpin <194402614+wrhalpin@users.noreply.github.com>
</commit_message>
<xml_diff>
--- a/GNAT-Presentation.pptx
+++ b/GNAT-Presentation.pptx
@@ -5088,7 +5088,55 @@
       </p:sp>
       <p:sp>
         <p:nvSpPr>
-          <p:cNvPr id="14" name="Text 12"/>
+          <p:cNvPr id="14" name="Shape 12"/>
+          <p:cNvSpPr/>
+          <p:nvPr/>
+        </p:nvSpPr>
+        <p:spPr>
+          <a:xfrm>
+            <a:off x="2834640" y="1655064"/>
+            <a:ext cx="0" cy="164592"/>
+          </a:xfrm>
+          <a:prstGeom prst="line">
+            <a:avLst/>
+          </a:prstGeom>
+          <a:noFill/>
+          <a:ln w="19050">
+            <a:solidFill>
+              <a:srgbClr val="0891B2"/>
+            </a:solidFill>
+            <a:prstDash val="solid"/>
+            <a:tailEnd type="triangle"/>
+          </a:ln>
+        </p:spPr>
+      </p:sp>
+      <p:sp>
+        <p:nvSpPr>
+          <p:cNvPr id="15" name="Shape 13"/>
+          <p:cNvSpPr/>
+          <p:nvPr/>
+        </p:nvSpPr>
+        <p:spPr>
+          <a:xfrm>
+            <a:off x="2834640" y="2615184"/>
+            <a:ext cx="0" cy="164592"/>
+          </a:xfrm>
+          <a:prstGeom prst="line">
+            <a:avLst/>
+          </a:prstGeom>
+          <a:noFill/>
+          <a:ln w="19050">
+            <a:solidFill>
+              <a:srgbClr val="0891B2"/>
+            </a:solidFill>
+            <a:prstDash val="solid"/>
+            <a:tailEnd type="triangle"/>
+          </a:ln>
+        </p:spPr>
+      </p:sp>
+      <p:sp>
+        <p:nvSpPr>
+          <p:cNvPr id="16" name="Text 14"/>
           <p:cNvSpPr/>
           <p:nvPr/>
         </p:nvSpPr>
@@ -6394,7 +6442,7 @@
       </p:graphicFrame>
       <p:sp>
         <p:nvSpPr>
-          <p:cNvPr id="16" name="Text 13"/>
+          <p:cNvPr id="18" name="Text 15"/>
           <p:cNvSpPr/>
           <p:nvPr/>
         </p:nvSpPr>
@@ -8141,6 +8189,78 @@
           </a:p>
         </p:txBody>
       </p:sp>
+      <p:sp>
+        <p:nvSpPr>
+          <p:cNvPr id="47" name="Shape 45"/>
+          <p:cNvSpPr/>
+          <p:nvPr/>
+        </p:nvSpPr>
+        <p:spPr>
+          <a:xfrm>
+            <a:off x="2212848" y="4160520"/>
+            <a:ext cx="237744" cy="0"/>
+          </a:xfrm>
+          <a:prstGeom prst="line">
+            <a:avLst/>
+          </a:prstGeom>
+          <a:noFill/>
+          <a:ln w="19050">
+            <a:solidFill>
+              <a:srgbClr val="0891B2"/>
+            </a:solidFill>
+            <a:prstDash val="solid"/>
+            <a:tailEnd type="triangle"/>
+          </a:ln>
+        </p:spPr>
+      </p:sp>
+      <p:sp>
+        <p:nvSpPr>
+          <p:cNvPr id="48" name="Shape 46"/>
+          <p:cNvSpPr/>
+          <p:nvPr/>
+        </p:nvSpPr>
+        <p:spPr>
+          <a:xfrm>
+            <a:off x="4361688" y="4160520"/>
+            <a:ext cx="237744" cy="0"/>
+          </a:xfrm>
+          <a:prstGeom prst="line">
+            <a:avLst/>
+          </a:prstGeom>
+          <a:noFill/>
+          <a:ln w="19050">
+            <a:solidFill>
+              <a:srgbClr val="0891B2"/>
+            </a:solidFill>
+            <a:prstDash val="solid"/>
+            <a:tailEnd type="triangle"/>
+          </a:ln>
+        </p:spPr>
+      </p:sp>
+      <p:sp>
+        <p:nvSpPr>
+          <p:cNvPr id="49" name="Shape 47"/>
+          <p:cNvSpPr/>
+          <p:nvPr/>
+        </p:nvSpPr>
+        <p:spPr>
+          <a:xfrm>
+            <a:off x="6510528" y="4160520"/>
+            <a:ext cx="237744" cy="0"/>
+          </a:xfrm>
+          <a:prstGeom prst="line">
+            <a:avLst/>
+          </a:prstGeom>
+          <a:noFill/>
+          <a:ln w="19050">
+            <a:solidFill>
+              <a:srgbClr val="0891B2"/>
+            </a:solidFill>
+            <a:prstDash val="solid"/>
+            <a:tailEnd type="triangle"/>
+          </a:ln>
+        </p:spPr>
+      </p:sp>
     </p:spTree>
   </p:cSld>
   <p:clrMapOvr>
@@ -28184,7 +28304,7 @@
             <a:avLst/>
           </a:prstGeom>
           <a:solidFill>
-            <a:srgbClr val="1E4D8C"/>
+            <a:srgbClr val="5B93D9"/>
           </a:solidFill>
           <a:ln w="12700">
             <a:solidFill>
@@ -28221,7 +28341,7 @@
             <a:r>
               <a:rPr lang="en-US" sz="850" b="1" dirty="0">
                 <a:solidFill>
-                  <a:srgbClr val="1E4D8C"/>
+                  <a:srgbClr val="5B93D9"/>
                 </a:solidFill>
                 <a:latin typeface="Calibri" pitchFamily="34" charset="0"/>
                 <a:ea typeface="Calibri" pitchFamily="34" charset="-122"/>
@@ -28454,7 +28574,7 @@
             <a:avLst/>
           </a:prstGeom>
           <a:solidFill>
-            <a:srgbClr val="1E4D8C"/>
+            <a:srgbClr val="5B93D9"/>
           </a:solidFill>
           <a:ln w="12700">
             <a:solidFill>
@@ -28491,7 +28611,7 @@
             <a:r>
               <a:rPr lang="en-US" sz="850" b="1" dirty="0">
                 <a:solidFill>
-                  <a:srgbClr val="1E4D8C"/>
+                  <a:srgbClr val="5B93D9"/>
                 </a:solidFill>
                 <a:latin typeface="Calibri" pitchFamily="34" charset="0"/>
                 <a:ea typeface="Calibri" pitchFamily="34" charset="-122"/>
@@ -28724,7 +28844,7 @@
             <a:avLst/>
           </a:prstGeom>
           <a:solidFill>
-            <a:srgbClr val="1E4D8C"/>
+            <a:srgbClr val="5B93D9"/>
           </a:solidFill>
           <a:ln w="12700">
             <a:solidFill>
@@ -28761,7 +28881,7 @@
             <a:r>
               <a:rPr lang="en-US" sz="850" b="1" dirty="0">
                 <a:solidFill>
-                  <a:srgbClr val="1E4D8C"/>
+                  <a:srgbClr val="5B93D9"/>
                 </a:solidFill>
                 <a:latin typeface="Calibri" pitchFamily="34" charset="0"/>
                 <a:ea typeface="Calibri" pitchFamily="34" charset="-122"/>
@@ -30088,7 +30208,7 @@
             <a:avLst/>
           </a:prstGeom>
           <a:solidFill>
-            <a:srgbClr val="162952"/>
+            <a:srgbClr val="06B6D4"/>
           </a:solidFill>
           <a:ln w="12700">
             <a:solidFill>

</xml_diff>

<commit_message>
Update presentation deck: 95→99 connectors, v1.1→v1.3.1, multi-LLM AI agents, new connector categories
Agent-Logs-Url: https://github.com/wrhalpin/GNAT/sessions/1df79fba-e3ba-4de5-9fe6-cb5bc2fa1896

Co-authored-by: wrhalpin <194402614+wrhalpin@users.noreply.github.com>
</commit_message>
<xml_diff>
--- a/GNAT-Presentation.pptx
+++ b/GNAT-Presentation.pptx
@@ -3375,7 +3375,7 @@
                 <a:ea typeface="Calibri" pitchFamily="34" charset="-122"/>
                 <a:cs typeface="Calibri" pitchFamily="34" charset="-120"/>
               </a:rPr>
-              <a:t>95 Connectors</a:t>
+              <a:t>99 Connectors</a:t>
             </a:r>
             <a:endParaRPr lang="en-US" sz="1000" dirty="0"/>
           </a:p>
@@ -3709,7 +3709,7 @@
                 <a:ea typeface="Calibri" pitchFamily="34" charset="-122"/>
                 <a:cs typeface="Calibri" pitchFamily="34" charset="-120"/>
               </a:rPr>
-              <a:t>Version 1.1  ·  Python 3.9+  ·  STIX 2.1  ·  95 Platform Connectors  ·  1,500+ Tests</a:t>
+              <a:t>Version 1.3.1  ·  Python 3.9+  ·  STIX 2.1  ·  99 Platform Connectors  ·  1,500+ Tests</a:t>
             </a:r>
             <a:endParaRPr lang="en-US" sz="1000" dirty="0"/>
           </a:p>
@@ -19069,7 +19069,7 @@
                 <a:ea typeface="Calibri" pitchFamily="34" charset="-122"/>
                 <a:cs typeface="Calibri" pitchFamily="34" charset="-120"/>
               </a:rPr>
-              <a:t>Every platform exposes get_object(), list_objects(), upsert_object(), to_stix(), from_stix(). Analysts learn one mental model once and it works across 95 platforms.</a:t>
+              <a:t>Every platform exposes get_object(), list_objects(), upsert_object(), to_stix(), from_stix(). Analysts learn one mental model once and it works across 99 platforms.</a:t>
             </a:r>
             <a:endParaRPr lang="en-US" sz="950" dirty="0"/>
           </a:p>
@@ -19747,7 +19747,7 @@
                 <a:ea typeface="Calibri" pitchFamily="34" charset="-122"/>
                 <a:cs typeface="Calibri" pitchFamily="34" charset="-120"/>
               </a:rPr>
-              <a:t>Python 3.8 / 3.9 / 3.10 matrix</a:t>
+              <a:t>Python 3.9 / 3.10 / 3.11 / 3.12 matrix</a:t>
             </a:r>
             <a:endParaRPr lang="en-US" sz="950" dirty="0"/>
           </a:p>
@@ -20992,7 +20992,7 @@
                 <a:ea typeface="Calibri" pitchFamily="34" charset="-122"/>
                 <a:cs typeface="Calibri" pitchFamily="34" charset="-120"/>
               </a:rPr>
-              <a:t>95</a:t>
+              <a:t>99</a:t>
             </a:r>
             <a:endParaRPr lang="en-US" sz="4200" dirty="0"/>
           </a:p>
@@ -24268,7 +24268,7 @@
                 <a:ea typeface="Calibri" pitchFamily="34" charset="-122"/>
                 <a:cs typeface="Calibri" pitchFamily="34" charset="-120"/>
               </a:rPr>
-              <a:t>CHANGELOG versions 0.6.0 – 1.1.0</a:t>
+              <a:t>CHANGELOG versions 0.6.0 – 1.3.1</a:t>
             </a:r>
             <a:endParaRPr lang="en-US" sz="850" dirty="0"/>
           </a:p>
@@ -24680,7 +24680,7 @@
                 <a:ea typeface="Calibri" pitchFamily="34" charset="-122"/>
                 <a:cs typeface="Calibri" pitchFamily="34" charset="-120"/>
               </a:rPr>
-              <a:t>Connectors Batch 2 — 11 new platforms</a:t>
+              <a:t>Connectors Batch 2 — 11 new platforms (v1.0)</a:t>
             </a:r>
             <a:endParaRPr lang="en-US" sz="850" dirty="0"/>
           </a:p>
@@ -24989,7 +24989,7 @@
                 <a:ea typeface="Calibri" pitchFamily="34" charset="-122"/>
                 <a:cs typeface="Calibri" pitchFamily="34" charset="-120"/>
               </a:rPr>
-              <a:t>Terminal UI (Textual, SSH-safe, 4 screens)</a:t>
+              <a:t>Terminal UI (Textual, SSH-safe, F1–F6 screens)</a:t>
             </a:r>
             <a:endParaRPr lang="en-US" sz="850" dirty="0"/>
           </a:p>
@@ -25916,7 +25916,7 @@
                 <a:ea typeface="Calibri" pitchFamily="34" charset="-122"/>
                 <a:cs typeface="Calibri" pitchFamily="34" charset="-120"/>
               </a:rPr>
-              <a:t>13 additional platform connectors (v1.1)</a:t>
+              <a:t>13 new connectors in v1.1 — 25 in v1.2 — 9 in v1.3</a:t>
             </a:r>
             <a:endParaRPr lang="en-US" sz="850" dirty="0"/>
           </a:p>
@@ -26019,7 +26019,7 @@
                 <a:ea typeface="Calibri" pitchFamily="34" charset="-122"/>
                 <a:cs typeface="Calibri" pitchFamily="34" charset="-120"/>
               </a:rPr>
-              <a:t>95 connectors total in CLIENT_REGISTRY</a:t>
+              <a:t>99 connectors total in CLIENT_REGISTRY</a:t>
             </a:r>
             <a:endParaRPr lang="en-US" sz="850" dirty="0"/>
           </a:p>
@@ -26122,7 +26122,7 @@
                 <a:ea typeface="Calibri" pitchFamily="34" charset="-122"/>
                 <a:cs typeface="Calibri" pitchFamily="34" charset="-120"/>
               </a:rPr>
-              <a:t>STIX validator ORM integration (validate=True)</a:t>
+              <a:t>LLMClient: Claude · OpenAI · Grok · Gemini (v1.3)</a:t>
             </a:r>
             <a:endParaRPr lang="en-US" sz="850" dirty="0"/>
           </a:p>
@@ -26289,7 +26289,7 @@
                 <a:ea typeface="Calibri" pitchFamily="34" charset="-122"/>
                 <a:cs typeface="Calibri" pitchFamily="34" charset="-120"/>
               </a:rPr>
-              <a:t>Reference: EXAMPLES.md  ·  IMPLEMENTATION_PLAN.md  ·  ARCHITECTURE_DECISIONS.md  ·  CHANGELOG.md  ·  PENDING_ITEMS.md</a:t>
+              <a:t>Reference: EXAMPLES.md  ·  IMPLEMENTATION_PLAN.md  ·  ARCHITECTURE_DECISIONS.md  ·  CHANGELOG.md</a:t>
             </a:r>
             <a:endParaRPr lang="en-US" sz="800" dirty="0"/>
           </a:p>
@@ -26464,7 +26464,7 @@
                 <a:ea typeface="Calibri" pitchFamily="34" charset="-122"/>
                 <a:cs typeface="Calibri" pitchFamily="34" charset="-120"/>
               </a:rPr>
-              <a:t>95 connectors · STIX 2.1 ORM · Ingest + Export pipelines</a:t>
+              <a:t>99 connectors · STIX 2.1 ORM · Ingest + Export pipelines</a:t>
             </a:r>
             <a:endParaRPr lang="en-US" sz="1300" dirty="0"/>
           </a:p>
@@ -26482,7 +26482,7 @@
                 <a:ea typeface="Calibri" pitchFamily="34" charset="-122"/>
                 <a:cs typeface="Calibri" pitchFamily="34" charset="-120"/>
               </a:rPr>
-              <a:t>AI agents (Claude + Copilot) · NLP queries · Research library · Report generation</a:t>
+              <a:t>AI agents (LLMClient: Claude · OpenAI · Grok · Gemini) · NLP queries · Research library · Report generation</a:t>
             </a:r>
             <a:endParaRPr lang="en-US" sz="1300" dirty="0"/>
           </a:p>
@@ -26580,7 +26580,7 @@
                 <a:ea typeface="Calibri" pitchFamily="34" charset="-122"/>
                 <a:cs typeface="Calibri" pitchFamily="34" charset="-120"/>
               </a:rPr>
-              <a:t>Version 1.1  |  Python 3.9+  |  Apache 2.0  |  EXAMPLES.md · IMPLEMENTATION_PLAN.md · README.md</a:t>
+              <a:t>Version 1.3.1  |  Python 3.9+  |  Apache 2.0  |  EXAMPLES.md · IMPLEMENTATION_PLAN.md · README.md</a:t>
             </a:r>
             <a:endParaRPr lang="en-US" sz="1000" dirty="0"/>
           </a:p>
@@ -27790,7 +27790,7 @@
                 <a:ea typeface="Calibri" pitchFamily="34" charset="-122"/>
                 <a:cs typeface="Calibri" pitchFamily="34" charset="-120"/>
               </a:rPr>
-              <a:t>CONNECTOR LAYER (95 platforms)</a:t>
+              <a:t>CONNECTOR LAYER (99 platforms)</a:t>
             </a:r>
             <a:endParaRPr lang="en-US" sz="1000" dirty="0"/>
           </a:p>
@@ -28116,7 +28116,7 @@
                 <a:ea typeface="Calibri" pitchFamily="34" charset="-122"/>
                 <a:cs typeface="Calibri" pitchFamily="34" charset="-120"/>
               </a:rPr>
-              <a:t>95 Platform Connectors — One Interface</a:t>
+              <a:t>99 Platform Connectors — One Interface</a:t>
             </a:r>
             <a:endParaRPr lang="en-US" sz="2000" dirty="0"/>
           </a:p>
@@ -28251,7 +28251,7 @@
                 <a:ea typeface="Calibri" pitchFamily="34" charset="-122"/>
                 <a:cs typeface="Calibri" pitchFamily="34" charset="-120"/>
               </a:rPr>
-              <a:t>ThreatQ · CrowdStrike · Recorded Future · AlienVault OTX · VirusTotal · ThreatConnect · Mandiant · MS Defender TI · ThreatStream · SOCRadar · PulseDive · FLARE · Yeti · CloudSEK · Feedly · MISP · OpenCTI · Group-IB · Cyble Vision · ZeroFox · ShadowServer</a:t>
+              <a:t>ThreatQ · CrowdStrike · Recorded Future · AlienVault OTX · VirusTotal · ThreatConnect · Mandiant · MS Defender TI · ThreatStream · SOCRadar · PulseDive · FLARE · Yeti · CloudSEK · Feedly · MISP · OpenCTI · Group-IB · Cyble Vision · ZeroFox · ShadowServer · BitSight · Flashpoint · HudsonRock · Intel 471 · UpGuard · Shodan · GreyNoise · CISA KEV · OSINT Feed</a:t>
             </a:r>
             <a:endParaRPr lang="en-US" sz="800" dirty="0"/>
           </a:p>
@@ -28386,7 +28386,7 @@
                 <a:ea typeface="Calibri" pitchFamily="34" charset="-122"/>
                 <a:cs typeface="Calibri" pitchFamily="34" charset="-120"/>
               </a:rPr>
-              <a:t>Splunk · Elastic SIEM · IBM QRadar · Microsoft Sentinel · Graylog · OSSIM · Security Onion · Wazuh</a:t>
+              <a:t>Splunk · Elastic SIEM · IBM QRadar · Microsoft Sentinel · Graylog · OSSIM · Security Onion · Wazuh · Google Chronicle · LogRhythm · Datadog</a:t>
             </a:r>
             <a:endParaRPr lang="en-US" sz="800" dirty="0"/>
           </a:p>
@@ -28521,7 +28521,7 @@
                 <a:ea typeface="Calibri" pitchFamily="34" charset="-122"/>
                 <a:cs typeface="Calibri" pitchFamily="34" charset="-120"/>
               </a:rPr>
-              <a:t>Palo Alto XSOAR · TheHive · GreyMatter · ServiceNow · Jira</a:t>
+              <a:t>Palo Alto XSOAR · TheHive · GreyMatter · ServiceNow · Jira · Synapse · FortiSOAR</a:t>
             </a:r>
             <a:endParaRPr lang="en-US" sz="800" dirty="0"/>
           </a:p>
@@ -28617,7 +28617,7 @@
                 <a:ea typeface="Calibri" pitchFamily="34" charset="-122"/>
                 <a:cs typeface="Calibri" pitchFamily="34" charset="-120"/>
               </a:rPr>
-              <a:t>VULNERABILITY MANAGEMENT</a:t>
+              <a:t>VULNERABILITY &amp; CLOUD SECURITY</a:t>
             </a:r>
             <a:endParaRPr lang="en-US" sz="850" dirty="0"/>
           </a:p>
@@ -28656,7 +28656,7 @@
                 <a:ea typeface="Calibri" pitchFamily="34" charset="-122"/>
                 <a:cs typeface="Calibri" pitchFamily="34" charset="-120"/>
               </a:rPr>
-              <a:t>Rapid7 InsightVM/IDR · Nucleus Security · Tenable One · Qualys VMDR · Greenbone/OpenVAS · DefectDojo</a:t>
+              <a:t>Rapid7 InsightVM/IDR · Nucleus Security · Tenable One · Qualys VMDR · Greenbone/OpenVAS · DefectDojo · Orca Security · Wiz CNAPP · Cortex Xpanse · CyCognito · RiskRecon · Armis Centrix · Axonius · Prisma Cloud · AWS Security Hub · JupiterOne · SecurityScorecard · Censys</a:t>
             </a:r>
             <a:endParaRPr lang="en-US" sz="800" dirty="0"/>
           </a:p>
@@ -28752,7 +28752,7 @@
                 <a:ea typeface="Calibri" pitchFamily="34" charset="-122"/>
                 <a:cs typeface="Calibri" pitchFamily="34" charset="-120"/>
               </a:rPr>
-              <a:t>CLOUD SECURITY &amp; ASM</a:t>
+              <a:t>NETWORK DETECTION &amp; ENDPOINT</a:t>
             </a:r>
             <a:endParaRPr lang="en-US" sz="850" dirty="0"/>
           </a:p>
@@ -28791,7 +28791,7 @@
                 <a:ea typeface="Calibri" pitchFamily="34" charset="-122"/>
                 <a:cs typeface="Calibri" pitchFamily="34" charset="-120"/>
               </a:rPr>
-              <a:t>Orca Security · Wiz CNAPP · Cortex Xpanse · CyCognito · RiskRecon · Armis Centrix · Axonius</a:t>
+              <a:t>Snort IDS · Suricata · Zeek · SentinelOne · Stellar Cyber · Netskope · ControlUp DEX · Whistic · Proofpoint · Darktrace · ExtraHop · Lansweeper · Vectra AI · Sophos · Trellix · Carbon Black · Tanium · Trend Micro Vision One · Cisco Umbrella · Cortex XDR · FortiEDR · FortiSIEM</a:t>
             </a:r>
             <a:endParaRPr lang="en-US" sz="800" dirty="0"/>
           </a:p>
@@ -28887,7 +28887,7 @@
                 <a:ea typeface="Calibri" pitchFamily="34" charset="-122"/>
                 <a:cs typeface="Calibri" pitchFamily="34" charset="-120"/>
               </a:rPr>
-              <a:t>NETWORK DETECTION &amp; ENDPOINT</a:t>
+              <a:t>OT/ICS &amp; INDUSTRY</a:t>
             </a:r>
             <a:endParaRPr lang="en-US" sz="850" dirty="0"/>
           </a:p>
@@ -28926,7 +28926,7 @@
                 <a:ea typeface="Calibri" pitchFamily="34" charset="-122"/>
                 <a:cs typeface="Calibri" pitchFamily="34" charset="-120"/>
               </a:rPr>
-              <a:t>Snort IDS · Suricata · Zeek · SentinelOne · Stellar Cyber · Netskope · ControlUp DEX · Whistic · Proofpoint</a:t>
+              <a:t>Dragos Platform · Claroty · Nozomi Networks · Cribl Stream</a:t>
             </a:r>
             <a:endParaRPr lang="en-US" sz="800" dirty="0"/>
           </a:p>
@@ -29061,7 +29061,7 @@
                 <a:ea typeface="Calibri" pitchFamily="34" charset="-122"/>
                 <a:cs typeface="Calibri" pitchFamily="34" charset="-120"/>
               </a:rPr>
-              <a:t>Microsoft Copilot for Security · OpenAI ChatGPT · Google Gemini · Grok AI</a:t>
+              <a:t>Microsoft Copilot for Security · OpenAI ChatGPT · Google Gemini · Grok AI · Discord</a:t>
             </a:r>
             <a:endParaRPr lang="en-US" sz="800" dirty="0"/>
           </a:p>
@@ -33197,7 +33197,7 @@
                 <a:ea typeface="Calibri" pitchFamily="34" charset="-122"/>
                 <a:cs typeface="Calibri" pitchFamily="34" charset="-120"/>
               </a:rPr>
-              <a:t>AI Agents — Claude-Powered Threat Research</a:t>
+              <a:t>AI Agents — Multi-LLM Threat Research</a:t>
             </a:r>
             <a:endParaRPr lang="en-US" sz="2000" dirty="0"/>
           </a:p>
@@ -33405,7 +33405,7 @@
                 <a:ea typeface="Calibri" pitchFamily="34" charset="-122"/>
                 <a:cs typeface="Calibri" pitchFamily="34" charset="-120"/>
               </a:rPr>
-              <a:t>Uses Claude API with web_search tool.</a:t>
+              <a:t>Backed by LLMClient (Claude / OpenAI / Grok / Gemini).</a:t>
             </a:r>
             <a:endParaRPr lang="en-US" sz="950" dirty="0"/>
           </a:p>
@@ -33666,7 +33666,7 @@
             <a:avLst/>
           </a:prstGeom>
           <a:solidFill>
-            <a:srgbClr val="162952"/>
+            <a:srgbClr val="06B6D4"/>
           </a:solidFill>
           <a:ln w="12700">
             <a:solidFill>
@@ -33709,7 +33709,7 @@
                 <a:ea typeface="Calibri" pitchFamily="34" charset="-122"/>
                 <a:cs typeface="Calibri" pitchFamily="34" charset="-120"/>
               </a:rPr>
-              <a:t>CopilotReader</a:t>
+              <a:t>LLMClient</a:t>
             </a:r>
             <a:endParaRPr lang="en-US" sz="1300" dirty="0"/>
           </a:p>
@@ -33748,7 +33748,7 @@
                 <a:ea typeface="Calibri" pitchFamily="34" charset="-122"/>
                 <a:cs typeface="Calibri" pitchFamily="34" charset="-120"/>
               </a:rPr>
-              <a:t>SourceReader</a:t>
+              <a:t>Unified Multi-LLM Facade</a:t>
             </a:r>
             <a:endParaRPr lang="en-US" sz="900" dirty="0"/>
           </a:p>
@@ -33787,7 +33787,7 @@
                 <a:ea typeface="Calibri" pitchFamily="34" charset="-122"/>
                 <a:cs typeface="Calibri" pitchFamily="34" charset="-120"/>
               </a:rPr>
-              <a:t>Query Microsoft Copilot via DirectLine for M365 content.</a:t>
+              <a:t>Single interface for Claude, OpenAI, Grok (xAI), and Gemini.</a:t>
             </a:r>
             <a:endParaRPr lang="en-US" sz="950" dirty="0"/>
           </a:p>
@@ -33804,7 +33804,7 @@
                 <a:ea typeface="Calibri" pitchFamily="34" charset="-122"/>
                 <a:cs typeface="Calibri" pitchFamily="34" charset="-120"/>
               </a:rPr>
-              <a:t>Sources: SharePoint libraries, mailboxes, Teams channels.</a:t>
+              <a:t>Automatic provider fallback on errors or rate limits.</a:t>
             </a:r>
             <a:endParaRPr lang="en-US" sz="950" dirty="0"/>
           </a:p>
@@ -33821,7 +33821,24 @@
                 <a:ea typeface="Calibri" pitchFamily="34" charset="-122"/>
                 <a:cs typeface="Calibri" pitchFamily="34" charset="-120"/>
               </a:rPr>
-              <a:t>Token exchange + auto-refresh. Output feeds directly into ParsingAgent.</a:t>
+              <a:t>Configured via [claude] / [openai] / [grok] / [gemini] INI sections.</a:t>
+            </a:r>
+            <a:endParaRPr lang="en-US" sz="950" dirty="0"/>
+          </a:p>
+          <a:p>
+            <a:pPr indent="0" marL="0">
+              <a:buNone/>
+            </a:pPr>
+            <a:r>
+              <a:rPr lang="en-US" sz="950" dirty="0">
+                <a:solidFill>
+                  <a:srgbClr val="94A3B8"/>
+                </a:solidFill>
+                <a:latin typeface="Calibri" pitchFamily="34" charset="0"/>
+                <a:ea typeface="Calibri" pitchFamily="34" charset="-122"/>
+                <a:cs typeface="Calibri" pitchFamily="34" charset="-120"/>
+              </a:rPr>
+              <a:t>Used by ResearchAgent, ParsingAgent, and ReportDraftingAssistant.</a:t>
             </a:r>
             <a:endParaRPr lang="en-US" sz="950" dirty="0"/>
           </a:p>
@@ -33861,7 +33878,7 @@
         <p:spPr>
           <a:xfrm>
             <a:off x="502920" y="3227832"/>
-            <a:ext cx="2743200" cy="228600"/>
+            <a:ext cx="4114800" cy="228600"/>
           </a:xfrm>
           <a:prstGeom prst="rect">
             <a:avLst/>
@@ -33885,7 +33902,7 @@
                 <a:ea typeface="Calibri" pitchFamily="34" charset="-122"/>
                 <a:cs typeface="Calibri" pitchFamily="34" charset="-120"/>
               </a:rPr>
-              <a:t>⚠  AI Trust Model</a:t>
+              <a:t>⚠  AI Trust Model · CopilotReader</a:t>
             </a:r>
             <a:endParaRPr lang="en-US" sz="1000" dirty="0"/>
           </a:p>
@@ -33924,7 +33941,7 @@
                 <a:ea typeface="Calibri" pitchFamily="34" charset="-122"/>
                 <a:cs typeface="Calibri" pitchFamily="34" charset="-120"/>
               </a:rPr>
-              <a:t>confidence_ceiling = 60 (configurable) prevents AI-extracted intel from reaching EDLs without analyst review. All AI objects tagged x_source_type='ai_extracted'. Export pipelines default to ConfidenceFilter(min=70), which excludes AI intel until promoted.</a:t>
+              <a:t>confidence_ceiling = 60 (configurable) prevents AI-extracted intel from reaching EDLs without analyst review. All AI objects tagged x_source_type='ai_extracted'. Export pipelines default to ConfidenceFilter(min=70), which excludes AI intel until promoted. CopilotReader queries Microsoft Copilot via DirectLine (SharePoint, mailboxes, Teams) and feeds output directly into ParsingAgent.</a:t>
             </a:r>
             <a:endParaRPr lang="en-US" sz="900" dirty="0"/>
           </a:p>

</xml_diff>

<commit_message>
Update documentation for telemetry, attribution, HuntGNAT, and infra labels
Sync all project documents to reflect this week's additions:
- CHANGELOG.md: add [Unreleased] entries for telemetry ingestion,
  infrastructure graph labels, HuntGNAT Phases 1-4, and attribution
  & campaign tracking
- CLAUDE.md: add telemetry, attribution, and HuntGNAT to repository
  layout; update reader/mapper counts (15/13); add telemetry and
  analysis extras to install examples
- README.md: add Attribution, HuntGNAT, and Telemetry rows to key
  capabilities table; update test count to 5,100+; add telemetry and
  analysis extras to install section
- docs/architecture.md: add HuntGNAT, Telemetry Ingestion, and
  Attribution subsystem descriptions; note infra_roles filter on
  GraphQuery
- Presentation: update test count to 5,100+; update closing slide
  with HuntGNAT, attribution, and telemetry highlights; rebuild PPTX

https://claude.ai/code/session_01H5UbjsuiiGya5n1eUCxoaR
</commit_message>
<xml_diff>
--- a/GNAT-Presentation.pptx
+++ b/GNAT-Presentation.pptx
@@ -4243,7 +4243,7 @@
                 <a:ea typeface="Calibri" pitchFamily="34" charset="-122"/>
                 <a:cs typeface="Calibri" pitchFamily="34" charset="-120"/>
               </a:rPr>
-              <a:t>Version 1.5.0  ·  Python 3.9+  ·  STIX 2.1  ·  158 Platform Connectors  ·  4,600+ Tests</a:t>
+              <a:t>Version 1.5.0  ·  Python 3.9+  ·  STIX 2.1  ·  158 Platform Connectors  ·  5,100+ Tests</a:t>
             </a:r>
             <a:endParaRPr lang="en-US" sz="1000" dirty="0"/>
           </a:p>
@@ -29663,7 +29663,7 @@
                 <a:ea typeface="Calibri" pitchFamily="34" charset="-122"/>
                 <a:cs typeface="Calibri" pitchFamily="34" charset="-120"/>
               </a:rPr>
-              <a:t>4,600+ unit tests across 40+ test files. Every connector, every pipeline stage, every renderer, every scheduler, every new v1.4/1.5 module. Confidence in changes without regression fear.</a:t>
+              <a:t>5,100+ unit tests across 40+ test files. Every connector, every pipeline stage, every renderer, every scheduler, every new v1.4/1.5 module. Confidence in changes without regression fear.</a:t>
             </a:r>
             <a:endParaRPr lang="en-US" sz="950" dirty="0"/>
           </a:p>
@@ -30477,7 +30477,7 @@
                 <a:ea typeface="Calibri" pitchFamily="34" charset="-122"/>
                 <a:cs typeface="Calibri" pitchFamily="34" charset="-120"/>
               </a:rPr>
-              <a:t>4,600+ unit tests across 40+ files</a:t>
+              <a:t>5,100+ unit tests across 40+ files</a:t>
             </a:r>
             <a:endParaRPr lang="en-US" sz="950" dirty="0"/>
           </a:p>
@@ -31977,7 +31977,7 @@
                 <a:ea typeface="Calibri" pitchFamily="34" charset="-122"/>
                 <a:cs typeface="Calibri" pitchFamily="34" charset="-120"/>
               </a:rPr>
-              <a:t>4,600+</a:t>
+              <a:t>5,100+</a:t>
             </a:r>
             <a:endParaRPr lang="en-US" sz="4200" dirty="0"/>
           </a:p>
@@ -38018,7 +38018,7 @@
                 <a:ea typeface="Calibri" pitchFamily="34" charset="-122"/>
                 <a:cs typeface="Calibri" pitchFamily="34" charset="-120"/>
               </a:rPr>
-              <a:t>158 connectors · STIX 2.1 ORM · Ingest + Export pipelines</a:t>
+              <a:t>158 connectors · STIX 2.1 ORM · Ingest + Export pipelines · Kafka telemetry ingestion</a:t>
             </a:r>
             <a:endParaRPr lang="en-US" sz="1300" dirty="0"/>
           </a:p>
@@ -38036,7 +38036,7 @@
                 <a:ea typeface="Calibri" pitchFamily="34" charset="-122"/>
                 <a:cs typeface="Calibri" pitchFamily="34" charset="-120"/>
               </a:rPr>
-              <a:t>AI agents (LLMClient: Claude · OpenAI · Grok · Gemini) · WorkflowEngine DAG · NLP queries · Research library</a:t>
+              <a:t>HuntGNAT: STIX → Sigma/YARA/Suricata/Snort · Hunt packages · ATT&amp;CK coverage · Drift detection</a:t>
             </a:r>
             <a:endParaRPr lang="en-US" sz="1300" dirty="0"/>
           </a:p>
@@ -38054,7 +38054,7 @@
                 <a:ea typeface="Calibri" pitchFamily="34" charset="-122"/>
                 <a:cs typeface="Calibri" pitchFamily="34" charset="-120"/>
               </a:rPr>
-              <a:t>TAXII 2.1 read+write · STIX validator · Policy RBAC · Plugins · Lineage · Metrics · Review Queue</a:t>
+              <a:t>Attribution: Campaign tracking · Diamond Model · Kill-chain · Actor profiles · Infrastructure classification</a:t>
             </a:r>
             <a:endParaRPr lang="en-US" sz="1300" dirty="0"/>
           </a:p>
@@ -38072,7 +38072,7 @@
                 <a:ea typeface="Calibri" pitchFamily="34" charset="-122"/>
                 <a:cs typeface="Calibri" pitchFamily="34" charset="-120"/>
               </a:rPr>
-              <a:t>Phase 4: ExecutionContext · HypothesisEngine · AgentGovernor · HITL  ·  4,600+ tests · ~$50/month Azure</a:t>
+              <a:t>AI agents (Claude · OpenAI · Grok · Gemini) · TAXII 2.1 · Policy RBAC  ·  5,100+ tests · ~$50/month Azure</a:t>
             </a:r>
             <a:endParaRPr lang="en-US" sz="1300" dirty="0"/>
           </a:p>

</xml_diff>

<commit_message>
Update all docs from v1.5.0/158 to v1.9.0/159
Sweep all documentation, presentation script, and PPTX for stale
version (1.5.0 -> 1.9.0) and connector count (158 -> 159) references.
CHANGELOG historical entries preserved as-is.

https://claude.ai/code/session_01H5UbjsuiiGya5n1eUCxoaR
</commit_message>
<xml_diff>
--- a/GNAT-Presentation.pptx
+++ b/GNAT-Presentation.pptx
@@ -3909,7 +3909,7 @@
                 <a:ea typeface="Calibri" pitchFamily="34" charset="-122"/>
                 <a:cs typeface="Calibri" pitchFamily="34" charset="-120"/>
               </a:rPr>
-              <a:t>158 Connectors</a:t>
+              <a:t>159 Connectors</a:t>
             </a:r>
             <a:endParaRPr lang="en-US" sz="1000" dirty="0"/>
           </a:p>
@@ -4243,7 +4243,7 @@
                 <a:ea typeface="Calibri" pitchFamily="34" charset="-122"/>
                 <a:cs typeface="Calibri" pitchFamily="34" charset="-120"/>
               </a:rPr>
-              <a:t>Version 1.5.0  ·  Python 3.9+  ·  STIX 2.1  ·  158 Platform Connectors  ·  5,100+ Tests</a:t>
+              <a:t>Version 1.9.0  ·  Python 3.9+  ·  STIX 2.1  ·  159 Platform Connectors  ·  5,100+ Tests</a:t>
             </a:r>
             <a:endParaRPr lang="en-US" sz="1000" dirty="0"/>
           </a:p>
@@ -28074,7 +28074,7 @@
                 <a:ea typeface="Calibri" pitchFamily="34" charset="-122"/>
                 <a:cs typeface="Calibri" pitchFamily="34" charset="-120"/>
               </a:rPr>
-              <a:t>TRUST_LEVEL on all 158 connectors</a:t>
+              <a:t>TRUST_LEVEL on all 159 connectors</a:t>
             </a:r>
             <a:endParaRPr lang="en-US" sz="900" dirty="0"/>
           </a:p>
@@ -28732,7 +28732,7 @@
                 <a:ea typeface="Calibri" pitchFamily="34" charset="-122"/>
                 <a:cs typeface="Calibri" pitchFamily="34" charset="-120"/>
               </a:rPr>
-              <a:t>ADRs 0039–0049  ·  TRUST_LEVEL on all 158 connectors  ·  Alembic migrations 0004–0008  ·  SimulationConnector · ReplayRunner · AgentTestHarness</a:t>
+              <a:t>ADRs 0039–0049  ·  TRUST_LEVEL on all 159 connectors  ·  Alembic migrations 0004–0008  ·  SimulationConnector · ReplayRunner · AgentTestHarness</a:t>
             </a:r>
             <a:endParaRPr lang="en-US" sz="800" dirty="0"/>
           </a:p>
@@ -29258,7 +29258,7 @@
                 <a:ea typeface="Calibri" pitchFamily="34" charset="-122"/>
                 <a:cs typeface="Calibri" pitchFamily="34" charset="-120"/>
               </a:rPr>
-              <a:t>Every platform exposes get_object(), list_objects(), upsert_object(), to_stix(), from_stix(). Analysts learn one mental model once and it works across 158 platforms.</a:t>
+              <a:t>Every platform exposes get_object(), list_objects(), upsert_object(), to_stix(), from_stix(). Analysts learn one mental model once and it works across 159 platforms.</a:t>
             </a:r>
             <a:endParaRPr lang="en-US" sz="950" dirty="0"/>
           </a:p>
@@ -31825,7 +31825,7 @@
                 <a:ea typeface="Calibri" pitchFamily="34" charset="-122"/>
                 <a:cs typeface="Calibri" pitchFamily="34" charset="-120"/>
               </a:rPr>
-              <a:t>158</a:t>
+              <a:t>159</a:t>
             </a:r>
             <a:endParaRPr lang="en-US" sz="4200" dirty="0"/>
           </a:p>
@@ -34380,7 +34380,7 @@
                 <a:ea typeface="Calibri" pitchFamily="34" charset="-122"/>
                 <a:cs typeface="Calibri" pitchFamily="34" charset="-120"/>
               </a:rPr>
-              <a:t>✓  Every pending item has shipped  —  v1.5.0 complete  ·  Phase 4 (v1.6) shipped</a:t>
+              <a:t>✓  Every pending item has shipped  —  v1.9.0 complete  ·  Phase 4 (v1.6) shipped</a:t>
             </a:r>
             <a:endParaRPr lang="en-US" sz="1300" dirty="0"/>
           </a:p>
@@ -36955,7 +36955,7 @@
                 <a:ea typeface="Calibri" pitchFamily="34" charset="-122"/>
                 <a:cs typeface="Calibri" pitchFamily="34" charset="-120"/>
               </a:rPr>
-              <a:t>158 connectors total in CLIENT_REGISTRY</a:t>
+              <a:t>159 connectors total in CLIENT_REGISTRY</a:t>
             </a:r>
             <a:endParaRPr lang="en-US" sz="800" dirty="0"/>
           </a:p>
@@ -38018,7 +38018,7 @@
                 <a:ea typeface="Calibri" pitchFamily="34" charset="-122"/>
                 <a:cs typeface="Calibri" pitchFamily="34" charset="-120"/>
               </a:rPr>
-              <a:t>158 connectors · STIX 2.1 ORM · Ingest + Export pipelines · Kafka telemetry ingestion</a:t>
+              <a:t>159 connectors · STIX 2.1 ORM · Ingest + Export pipelines · Kafka telemetry ingestion</a:t>
             </a:r>
             <a:endParaRPr lang="en-US" sz="1300" dirty="0"/>
           </a:p>
@@ -38134,7 +38134,7 @@
                 <a:ea typeface="Calibri" pitchFamily="34" charset="-122"/>
                 <a:cs typeface="Calibri" pitchFamily="34" charset="-120"/>
               </a:rPr>
-              <a:t>Version 1.5.0  |  Python 3.9+  |  Apache 2.0  |  EXAMPLES.md · IMPLEMENTATION_PLAN.md · README.md</a:t>
+              <a:t>Version 1.9.0  |  Python 3.9+  |  Apache 2.0  |  EXAMPLES.md · IMPLEMENTATION_PLAN.md · README.md</a:t>
             </a:r>
             <a:endParaRPr lang="en-US" sz="1000" dirty="0"/>
           </a:p>
@@ -38700,7 +38700,7 @@
                 <a:ea typeface="Calibri" pitchFamily="34" charset="-122"/>
                 <a:cs typeface="Calibri" pitchFamily="34" charset="-120"/>
               </a:rPr>
-              <a:t>CONNECTOR LAYER (158 platforms)</a:t>
+              <a:t>CONNECTOR LAYER (159 platforms)</a:t>
             </a:r>
             <a:endParaRPr lang="en-US" sz="1000" dirty="0"/>
           </a:p>
@@ -39090,7 +39090,7 @@
                 <a:ea typeface="Calibri" pitchFamily="34" charset="-122"/>
                 <a:cs typeface="Calibri" pitchFamily="34" charset="-120"/>
               </a:rPr>
-              <a:t>158 Platform Connectors — One Interface</a:t>
+              <a:t>159 Platform Connectors — One Interface</a:t>
             </a:r>
             <a:endParaRPr lang="en-US" sz="2000" dirty="0"/>
           </a:p>

</xml_diff>